<commit_message>
added a few baseline onlys
</commit_message>
<xml_diff>
--- a/Writing/thesis/schematics.pptx
+++ b/Writing/thesis/schematics.pptx
@@ -197,7 +197,7 @@
           <a:p>
             <a:fld id="{D6849394-DEC3-9448-BB9C-504DDE178331}" type="datetimeFigureOut">
               <a:rPr lang="en-US" smtClean="0"/>
-              <a:t>10/27/25</a:t>
+              <a:t>3/27/26</a:t>
             </a:fld>
             <a:endParaRPr lang="en-US"/>
           </a:p>
@@ -695,7 +695,7 @@
           <a:p>
             <a:fld id="{8505A7DA-9F43-5B46-81ED-F4D45E6DB0AD}" type="datetimeFigureOut">
               <a:rPr lang="en-US" smtClean="0"/>
-              <a:t>10/27/25</a:t>
+              <a:t>3/27/26</a:t>
             </a:fld>
             <a:endParaRPr lang="en-US"/>
           </a:p>
@@ -893,7 +893,7 @@
           <a:p>
             <a:fld id="{8505A7DA-9F43-5B46-81ED-F4D45E6DB0AD}" type="datetimeFigureOut">
               <a:rPr lang="en-US" smtClean="0"/>
-              <a:t>10/27/25</a:t>
+              <a:t>3/27/26</a:t>
             </a:fld>
             <a:endParaRPr lang="en-US"/>
           </a:p>
@@ -1101,7 +1101,7 @@
           <a:p>
             <a:fld id="{8505A7DA-9F43-5B46-81ED-F4D45E6DB0AD}" type="datetimeFigureOut">
               <a:rPr lang="en-US" smtClean="0"/>
-              <a:t>10/27/25</a:t>
+              <a:t>3/27/26</a:t>
             </a:fld>
             <a:endParaRPr lang="en-US"/>
           </a:p>
@@ -1299,7 +1299,7 @@
           <a:p>
             <a:fld id="{8505A7DA-9F43-5B46-81ED-F4D45E6DB0AD}" type="datetimeFigureOut">
               <a:rPr lang="en-US" smtClean="0"/>
-              <a:t>10/27/25</a:t>
+              <a:t>3/27/26</a:t>
             </a:fld>
             <a:endParaRPr lang="en-US"/>
           </a:p>
@@ -1574,7 +1574,7 @@
           <a:p>
             <a:fld id="{8505A7DA-9F43-5B46-81ED-F4D45E6DB0AD}" type="datetimeFigureOut">
               <a:rPr lang="en-US" smtClean="0"/>
-              <a:t>10/27/25</a:t>
+              <a:t>3/27/26</a:t>
             </a:fld>
             <a:endParaRPr lang="en-US"/>
           </a:p>
@@ -1839,7 +1839,7 @@
           <a:p>
             <a:fld id="{8505A7DA-9F43-5B46-81ED-F4D45E6DB0AD}" type="datetimeFigureOut">
               <a:rPr lang="en-US" smtClean="0"/>
-              <a:t>10/27/25</a:t>
+              <a:t>3/27/26</a:t>
             </a:fld>
             <a:endParaRPr lang="en-US"/>
           </a:p>
@@ -2251,7 +2251,7 @@
           <a:p>
             <a:fld id="{8505A7DA-9F43-5B46-81ED-F4D45E6DB0AD}" type="datetimeFigureOut">
               <a:rPr lang="en-US" smtClean="0"/>
-              <a:t>10/27/25</a:t>
+              <a:t>3/27/26</a:t>
             </a:fld>
             <a:endParaRPr lang="en-US"/>
           </a:p>
@@ -2392,7 +2392,7 @@
           <a:p>
             <a:fld id="{8505A7DA-9F43-5B46-81ED-F4D45E6DB0AD}" type="datetimeFigureOut">
               <a:rPr lang="en-US" smtClean="0"/>
-              <a:t>10/27/25</a:t>
+              <a:t>3/27/26</a:t>
             </a:fld>
             <a:endParaRPr lang="en-US"/>
           </a:p>
@@ -2505,7 +2505,7 @@
           <a:p>
             <a:fld id="{8505A7DA-9F43-5B46-81ED-F4D45E6DB0AD}" type="datetimeFigureOut">
               <a:rPr lang="en-US" smtClean="0"/>
-              <a:t>10/27/25</a:t>
+              <a:t>3/27/26</a:t>
             </a:fld>
             <a:endParaRPr lang="en-US"/>
           </a:p>
@@ -2816,7 +2816,7 @@
           <a:p>
             <a:fld id="{8505A7DA-9F43-5B46-81ED-F4D45E6DB0AD}" type="datetimeFigureOut">
               <a:rPr lang="en-US" smtClean="0"/>
-              <a:t>10/27/25</a:t>
+              <a:t>3/27/26</a:t>
             </a:fld>
             <a:endParaRPr lang="en-US"/>
           </a:p>
@@ -3104,7 +3104,7 @@
           <a:p>
             <a:fld id="{8505A7DA-9F43-5B46-81ED-F4D45E6DB0AD}" type="datetimeFigureOut">
               <a:rPr lang="en-US" smtClean="0"/>
-              <a:t>10/27/25</a:t>
+              <a:t>3/27/26</a:t>
             </a:fld>
             <a:endParaRPr lang="en-US"/>
           </a:p>
@@ -3345,7 +3345,7 @@
           <a:p>
             <a:fld id="{8505A7DA-9F43-5B46-81ED-F4D45E6DB0AD}" type="datetimeFigureOut">
               <a:rPr lang="en-US" smtClean="0"/>
-              <a:t>10/27/25</a:t>
+              <a:t>3/27/26</a:t>
             </a:fld>
             <a:endParaRPr lang="en-US"/>
           </a:p>
@@ -4373,13 +4373,14 @@
           <p:cNvCxnSpPr>
             <a:cxnSpLocks/>
             <a:stCxn id="47" idx="2"/>
+            <a:endCxn id="50" idx="2"/>
           </p:cNvCxnSpPr>
           <p:nvPr/>
         </p:nvCxnSpPr>
         <p:spPr>
-          <a:xfrm flipH="1">
-            <a:off x="3831752" y="3026226"/>
-            <a:ext cx="9" cy="1785245"/>
+          <a:xfrm>
+            <a:off x="3831761" y="3026226"/>
+            <a:ext cx="3" cy="990587"/>
           </a:xfrm>
           <a:prstGeom prst="line">
             <a:avLst/>
@@ -4405,60 +4406,6 @@
           </a:fontRef>
         </p:style>
       </p:cxnSp>
-      <p:sp>
-        <p:nvSpPr>
-          <p:cNvPr id="52" name="Triangle 51">
-            <a:extLst>
-              <a:ext uri="{FF2B5EF4-FFF2-40B4-BE49-F238E27FC236}">
-                <a16:creationId xmlns:a16="http://schemas.microsoft.com/office/drawing/2014/main" id="{B417186F-80F1-6768-629E-EC605572E8A4}"/>
-              </a:ext>
-            </a:extLst>
-          </p:cNvPr>
-          <p:cNvSpPr/>
-          <p:nvPr/>
-        </p:nvSpPr>
-        <p:spPr>
-          <a:xfrm rot="10800000">
-            <a:off x="3760995" y="4713499"/>
-            <a:ext cx="141514" cy="119742"/>
-          </a:xfrm>
-          <a:prstGeom prst="triangle">
-            <a:avLst/>
-          </a:prstGeom>
-          <a:solidFill>
-            <a:schemeClr val="tx1"/>
-          </a:solidFill>
-          <a:ln>
-            <a:solidFill>
-              <a:schemeClr val="tx1"/>
-            </a:solidFill>
-          </a:ln>
-        </p:spPr>
-        <p:style>
-          <a:lnRef idx="2">
-            <a:schemeClr val="accent1">
-              <a:shade val="15000"/>
-            </a:schemeClr>
-          </a:lnRef>
-          <a:fillRef idx="1">
-            <a:schemeClr val="accent1"/>
-          </a:fillRef>
-          <a:effectRef idx="0">
-            <a:schemeClr val="accent1"/>
-          </a:effectRef>
-          <a:fontRef idx="minor">
-            <a:schemeClr val="lt1"/>
-          </a:fontRef>
-        </p:style>
-        <p:txBody>
-          <a:bodyPr rtlCol="0" anchor="ctr"/>
-          <a:lstStyle/>
-          <a:p>
-            <a:pPr algn="ctr"/>
-            <a:endParaRPr lang="en-US"/>
-          </a:p>
-        </p:txBody>
-      </p:sp>
       <p:sp>
         <p:nvSpPr>
           <p:cNvPr id="53" name="Triangle 52">
@@ -4564,80 +4511,6 @@
           <a:p>
             <a:pPr algn="ctr"/>
             <a:endParaRPr lang="en-US"/>
-          </a:p>
-        </p:txBody>
-      </p:sp>
-      <p:sp>
-        <p:nvSpPr>
-          <p:cNvPr id="55" name="Rectangle 54">
-            <a:extLst>
-              <a:ext uri="{FF2B5EF4-FFF2-40B4-BE49-F238E27FC236}">
-                <a16:creationId xmlns:a16="http://schemas.microsoft.com/office/drawing/2014/main" id="{B9CB18E1-33B4-2185-6B78-73DB3C4E33C8}"/>
-              </a:ext>
-            </a:extLst>
-          </p:cNvPr>
-          <p:cNvSpPr/>
-          <p:nvPr/>
-        </p:nvSpPr>
-        <p:spPr>
-          <a:xfrm>
-            <a:off x="2875305" y="4981285"/>
-            <a:ext cx="1912881" cy="548641"/>
-          </a:xfrm>
-          <a:prstGeom prst="rect">
-            <a:avLst/>
-          </a:prstGeom>
-          <a:solidFill>
-            <a:schemeClr val="bg2">
-              <a:lumMod val="90000"/>
-            </a:schemeClr>
-          </a:solidFill>
-          <a:ln>
-            <a:solidFill>
-              <a:schemeClr val="tx1"/>
-            </a:solidFill>
-          </a:ln>
-        </p:spPr>
-        <p:style>
-          <a:lnRef idx="2">
-            <a:schemeClr val="accent1">
-              <a:shade val="15000"/>
-            </a:schemeClr>
-          </a:lnRef>
-          <a:fillRef idx="1">
-            <a:schemeClr val="accent1"/>
-          </a:fillRef>
-          <a:effectRef idx="0">
-            <a:schemeClr val="accent1"/>
-          </a:effectRef>
-          <a:fontRef idx="minor">
-            <a:schemeClr val="lt1"/>
-          </a:fontRef>
-        </p:style>
-        <p:txBody>
-          <a:bodyPr rtlCol="0" anchor="ctr"/>
-          <a:lstStyle/>
-          <a:p>
-            <a:pPr algn="ctr"/>
-            <a:r>
-              <a:rPr lang="en-US" sz="1400" dirty="0">
-                <a:solidFill>
-                  <a:schemeClr val="tx1"/>
-                </a:solidFill>
-              </a:rPr>
-              <a:t>Mifepristone injection</a:t>
-            </a:r>
-          </a:p>
-          <a:p>
-            <a:pPr algn="ctr"/>
-            <a:r>
-              <a:rPr lang="en-US" sz="1200" dirty="0">
-                <a:solidFill>
-                  <a:schemeClr val="tx1"/>
-                </a:solidFill>
-              </a:rPr>
-              <a:t>n = #</a:t>
-            </a:r>
           </a:p>
         </p:txBody>
       </p:sp>
@@ -4699,7 +4572,7 @@
                   <a:schemeClr val="tx1"/>
                 </a:solidFill>
               </a:rPr>
-              <a:t>No injection</a:t>
+              <a:t>5uM AM251</a:t>
             </a:r>
           </a:p>
           <a:p>
@@ -4773,7 +4646,7 @@
                   <a:schemeClr val="tx1"/>
                 </a:solidFill>
               </a:rPr>
-              <a:t>Vehicle injection </a:t>
+              <a:t>Control solution</a:t>
             </a:r>
           </a:p>
           <a:p>

</xml_diff>